<commit_message>
docs: deck updated with the trigger-validation result
</commit_message>
<xml_diff>
--- a/docs/presentation.pptx
+++ b/docs/presentation.pptx
@@ -113,37 +113,37 @@
   <p:extLst>
     <p:ext uri="{521415D9-36F7-43E2-AB2F-B90AF26B5E84}">
       <p14:sectionLst xmlns:p14="http://schemas.microsoft.com/office/powerpoint/2010/main">
-        <p14:section name="Title" id="{16d425a2-43c0-e24e-67bc-f3c0da62846f}">
+        <p14:section name="Title" id="{89e5f86d-af84-8d28-75ba-af066b68d765}">
           <p14:sldIdLst>
             <p14:sldId id="256"/>
           </p14:sldIdLst>
         </p14:section>
-        <p14:section name="Problem &amp; Approach" id="{3148b3a3-391f-f2d7-3aab-f9ad6908f566}">
+        <p14:section name="Problem &amp; Approach" id="{312e3a31-2634-27c1-bd74-705385fd940a}">
           <p14:sldIdLst>
             <p14:sldId id="257"/>
           </p14:sldIdLst>
         </p14:section>
-        <p14:section name="System Design" id="{64a7739f-fe80-4002-fea1-66e4b55dbe09}">
+        <p14:section name="System Design" id="{a102bce4-d542-2fec-56a6-80a86b77aeec}">
           <p14:sldIdLst>
             <p14:sldId id="258"/>
           </p14:sldIdLst>
         </p14:section>
-        <p14:section name="Implementation Highlights" id="{13896d3e-198a-9385-44b9-b7c1468c84d3}">
+        <p14:section name="Implementation Highlights" id="{f5ad97c2-7cf0-69b2-acc8-f80879a17f87}">
           <p14:sldIdLst>
             <p14:sldId id="259"/>
           </p14:sldIdLst>
         </p14:section>
-        <p14:section name="Key Results" id="{41b88597-de74-7e62-21fd-47b73178cc61}">
+        <p14:section name="Key Results" id="{623f8d21-61d5-520f-44a2-77a776f564f8}">
           <p14:sldIdLst>
             <p14:sldId id="260"/>
           </p14:sldIdLst>
         </p14:section>
-        <p14:section name="Domain Impact" id="{42336d5d-5e36-c298-4648-566513fba1de}">
+        <p14:section name="Domain Impact" id="{744c5114-b126-582e-2d68-7a0e984919da}">
           <p14:sldIdLst>
             <p14:sldId id="261"/>
           </p14:sldIdLst>
         </p14:section>
-        <p14:section name="Limitations &amp; Next Steps" id="{c85bd8e9-1723-a486-5978-093731b397a0}">
+        <p14:section name="Limitations &amp; Next Steps" id="{282ba3d8-2a35-891f-240f-ef1c0e6b4607}">
           <p14:sldIdLst>
             <p14:sldId id="262"/>
           </p14:sldIdLst>
@@ -1134,7 +1134,7 @@
           <a:p>
             <a:r>
               <a:rPr lang="en-US" dirty="0"/>
-              <a:t>At midnight UTC on 22 February 2022, RiskPulse triggered a geopolitical stress test: Russia had recognised two separatist regions of Ukraine. Six hours later it fired again on the troop order. The full-scale invasion began two days later. This came from replaying a year of real news and tweets through the system in time order, with no look-ahead. I'm Arnav Gupta from IIIT Dharwad. RiskPulse turns unstructured text into risk signals and acts on them, with both downstream modules built. Wording rule: the system flagged the escalation; never say it predicted the invasion.</a:t>
+              <a:t>At midnight UTC on 22 February 2022, RiskPulse triggered a geopolitical stress test: Russia had recognised two separatist regions of Ukraine. Six hours later it fired again on the troop order. The full-scale invasion began two days later. This came from replaying a year of real news and tweets through the system in time order, with no look-ahead. It is one episode, not proof of skill: slide 7 shows that across the whole year, trigger timing matched random days. I'm Arnav Gupta from IIIT Dharwad. RiskPulse turns unstructured text into risk signals and acts on them, with both downstream modules built. Wording rule: the system flagged the escalation; never say it predicted the invasion.</a:t>
             </a:r>
             <a:endParaRPr lang="en-US" dirty="0"/>
           </a:p>
@@ -1662,7 +1662,7 @@
           <a:p>
             <a:r>
               <a:rPr lang="en-US" dirty="0"/>
-              <a:t>Here is where it breaks. Two rounds of event classification, with 500 hand labels and a blind test, did not beat a keyword baseline. Market-wide impact doesn't predict market moves. The scenario underestimated the oil shock because my analogues mix risk-off with supply shocks, and the June 2022 Fed hike was missed because scheduled events are priced in: what moves markets is the surprise against consensus. Trigger precision against market stress days wasn't measured in this build. Each of these has a concrete next step. And every decision rule was written down before the test it governed, every look at the test window is logged, and weak results are reported rather than tuned away. We used 2022 to find where the method breaks, not to tune it until it looks right. Thank you.</a:t>
+              <a:t>Here is where it breaks. Two rounds of event classification, with 500 hand labels and a blind test, did not beat a keyword baseline. Market-wide impact doesn't predict market moves. The scenario underestimated the oil shock because my analogues mix risk-off with supply shocks, and the June 2022 Fed hike was missed because scheduled events are priced in: what moves markets is the surprise against consensus. And when I tested trigger timing against real market stress days, with the definition fixed in advance, it was no better than random: 26.4% precision against 26.6%, because the triggers fire on 71% of sessions. The value of Module B today is the explainable stress computation once an event is flagged, not the timing. Each of these has a concrete next step. And every decision rule was written down before the test it governed, every look at the test window is logged, and weak results are reported rather than tuned away. We used 2022 to find where the method breaks, not to tune it until it looks right. Thank you.</a:t>
             </a:r>
             <a:endParaRPr lang="en-US" dirty="0"/>
           </a:p>
@@ -3173,8 +3173,8 @@
         </p:nvSpPr>
         <p:spPr>
           <a:xfrm>
-            <a:off x="7360920" y="5440680"/>
-            <a:ext cx="3931920" cy="548640"/>
+            <a:off x="7360920" y="5303520"/>
+            <a:ext cx="3931920" cy="731520"/>
           </a:xfrm>
           <a:prstGeom prst="rect">
             <a:avLst/>
@@ -3195,7 +3195,7 @@
                   <a:srgbClr val="9FB0C7"/>
                 </a:solidFill>
               </a:rPr>
-              <a:t>Real 2021–22 news and tweets, processed in time order with no look-ahead. The stressed book is a synthetic USD 10 bn wholesale portfolio.</a:t>
+              <a:t>Real 2021–22 news and tweets, replayed with no look-ahead; synthetic USD 10 bn book. One episode, not proof of skill: across the year, trigger timing matched random days (slide 7).</a:t>
             </a:r>
             <a:endParaRPr lang="en-US" sz="950" dirty="0"/>
           </a:p>
@@ -7956,7 +7956,7 @@
                   <a:schemeClr val="tx2"/>
                 </a:solidFill>
               </a:rPr>
-              <a:t>learned impact ≈ 2.0× the hand-set score's link to market moves  ·  FinBERT +0.121 macro-F1 over VADER  ·  3,382 high-impact items filtered to 345 stress tests a year  ·  dedup removes 39.0% of news</a:t>
+              <a:t>learned impact ≈ 2.0× the hand-set score's link to market moves  ·  FinBERT +0.121 macro-F1 over VADER  ·  dedup removes 39.0% of news</a:t>
             </a:r>
             <a:endParaRPr lang="en-US" sz="1100" dirty="0"/>
           </a:p>
@@ -8111,7 +8111,7 @@
                 <a:ea typeface="Cambria" pitchFamily="34" charset="-122"/>
                 <a:cs typeface="Cambria" pitchFamily="34" charset="-120"/>
               </a:rPr>
-              <a:t>Built for the people who act on risk: an early warning with a full audit trail</a:t>
+              <a:t>Built for the people who act on risk: explainable stress tests with a full audit trail</a:t>
             </a:r>
             <a:endParaRPr lang="en-US" sz="2500" dirty="0"/>
           </a:p>
@@ -9459,7 +9459,7 @@
                   </a:tcPr>
                 </a:tc>
               </a:tr>
-              <a:tr h="804672">
+              <a:tr h="777240">
                 <a:tc>
                   <a:txBody>
                     <a:bodyPr/>
@@ -9665,7 +9665,7 @@
                   </a:tcPr>
                 </a:tc>
               </a:tr>
-              <a:tr h="804672">
+              <a:tr h="777240">
                 <a:tc>
                   <a:txBody>
                     <a:bodyPr/>
@@ -9871,7 +9871,7 @@
                   </a:tcPr>
                 </a:tc>
               </a:tr>
-              <a:tr h="804672">
+              <a:tr h="777240">
                 <a:tc>
                   <a:txBody>
                     <a:bodyPr/>
@@ -10077,7 +10077,7 @@
                   </a:tcPr>
                 </a:tc>
               </a:tr>
-              <a:tr h="685800">
+              <a:tr h="658368">
                 <a:tc>
                   <a:txBody>
                     <a:bodyPr/>
@@ -10283,7 +10283,7 @@
                   </a:tcPr>
                 </a:tc>
               </a:tr>
-              <a:tr h="685800">
+              <a:tr h="868680">
                 <a:tc>
                   <a:txBody>
                     <a:bodyPr/>
@@ -10301,7 +10301,7 @@
                           <a:ea typeface="Calibri" pitchFamily="34" charset="-122"/>
                           <a:cs typeface="Calibri" pitchFamily="34" charset="-120"/>
                         </a:rPr>
-                        <a:t>Trigger precision against VIX / SPY stress days not yet measured</a:t>
+                        <a:t>Trigger timing no better than random: precision 26.4% vs 26.6% for random days; fires on 71% of sessions</a:t>
                       </a:r>
                       <a:endParaRPr lang="en-US" sz="1100" dirty="0">
                         <a:latin typeface="Calibri" charset="0"/>
@@ -10369,7 +10369,7 @@
                           <a:ea typeface="Calibri" pitchFamily="34" charset="-122"/>
                           <a:cs typeface="Calibri" pitchFamily="34" charset="-120"/>
                         </a:rPr>
-                        <a:t>Not reached in this build</a:t>
+                        <a:t>Market-wide impact isn't predictive, so triggers aren't selective</a:t>
                       </a:r>
                       <a:endParaRPr lang="en-US" sz="1100" dirty="0">
                         <a:latin typeface="Calibri" charset="0"/>
@@ -10437,7 +10437,7 @@
                           <a:ea typeface="Calibri" pitchFamily="34" charset="-122"/>
                           <a:cs typeface="Calibri" pitchFamily="34" charset="-120"/>
                         </a:rPr>
-                        <a:t>Validate triggers against market stress markers</a:t>
+                        <a:t>Market-level impact model; a pre-registered alert budget</a:t>
                       </a:r>
                       <a:endParaRPr lang="en-US" sz="1100" dirty="0">
                         <a:latin typeface="Calibri" charset="0"/>

</xml_diff>

<commit_message>
docs: deck slide 7 adds the trigger-timing cause and next step
</commit_message>
<xml_diff>
--- a/docs/presentation.pptx
+++ b/docs/presentation.pptx
@@ -113,37 +113,37 @@
   <p:extLst>
     <p:ext uri="{521415D9-36F7-43E2-AB2F-B90AF26B5E84}">
       <p14:sectionLst xmlns:p14="http://schemas.microsoft.com/office/powerpoint/2010/main">
-        <p14:section name="Title" id="{89e5f86d-af84-8d28-75ba-af066b68d765}">
+        <p14:section name="Title" id="{a7271026-979e-218a-388a-835452acbe89}">
           <p14:sldIdLst>
             <p14:sldId id="256"/>
           </p14:sldIdLst>
         </p14:section>
-        <p14:section name="Problem &amp; Approach" id="{312e3a31-2634-27c1-bd74-705385fd940a}">
+        <p14:section name="Problem &amp; Approach" id="{23ab4bb0-be91-80ec-1c00-cf16443be444}">
           <p14:sldIdLst>
             <p14:sldId id="257"/>
           </p14:sldIdLst>
         </p14:section>
-        <p14:section name="System Design" id="{a102bce4-d542-2fec-56a6-80a86b77aeec}">
+        <p14:section name="System Design" id="{326dbaa3-af50-63be-98eb-cb6133498724}">
           <p14:sldIdLst>
             <p14:sldId id="258"/>
           </p14:sldIdLst>
         </p14:section>
-        <p14:section name="Implementation Highlights" id="{f5ad97c2-7cf0-69b2-acc8-f80879a17f87}">
+        <p14:section name="Implementation Highlights" id="{3a506bb3-08d3-0b07-9ebb-999b117aeeae}">
           <p14:sldIdLst>
             <p14:sldId id="259"/>
           </p14:sldIdLst>
         </p14:section>
-        <p14:section name="Key Results" id="{623f8d21-61d5-520f-44a2-77a776f564f8}">
+        <p14:section name="Key Results" id="{032f5ad8-89a2-809d-728c-a164d6c7e9c6}">
           <p14:sldIdLst>
             <p14:sldId id="260"/>
           </p14:sldIdLst>
         </p14:section>
-        <p14:section name="Domain Impact" id="{744c5114-b126-582e-2d68-7a0e984919da}">
+        <p14:section name="Domain Impact" id="{598f496a-8b5a-e07c-63d5-981c25dde9e3}">
           <p14:sldIdLst>
             <p14:sldId id="261"/>
           </p14:sldIdLst>
         </p14:section>
-        <p14:section name="Limitations &amp; Next Steps" id="{282ba3d8-2a35-891f-240f-ef1c0e6b4607}">
+        <p14:section name="Limitations &amp; Next Steps" id="{989f8dea-0647-ad50-ccca-3897f72a59de}">
           <p14:sldIdLst>
             <p14:sldId id="262"/>
           </p14:sldIdLst>
@@ -1662,7 +1662,7 @@
           <a:p>
             <a:r>
               <a:rPr lang="en-US" dirty="0"/>
-              <a:t>Here is where it breaks. Two rounds of event classification, with 500 hand labels and a blind test, did not beat a keyword baseline. Market-wide impact doesn't predict market moves. The scenario underestimated the oil shock because my analogues mix risk-off with supply shocks, and the June 2022 Fed hike was missed because scheduled events are priced in: what moves markets is the surprise against consensus. And when I tested trigger timing against real market stress days, with the definition fixed in advance, it was no better than random: 26.4% precision against 26.6%, because the triggers fire on 71% of sessions. The value of Module B today is the explainable stress computation once an event is flagged, not the timing. Each of these has a concrete next step. And every decision rule was written down before the test it governed, every look at the test window is logged, and weak results are reported rather than tuned away. We used 2022 to find where the method breaks, not to tune it until it looks right. Thank you.</a:t>
+              <a:t>Here is where it breaks. Two rounds of event classification, with 500 hand labels and a blind test, did not beat a keyword baseline. Market-wide impact doesn't predict market moves. The scenario underestimated the oil shock because my analogues mix risk-off with supply shocks, and the June 2022 Fed hike was missed because scheduled events are priced in: what moves markets is the surprise against consensus. And when I tested trigger timing against real market stress days, with the definition fixed in advance, it was no better than random: 26.4% precision against 26.6%. The trigger threshold is relative, the top 5% of items, and with this much news it is crossed on 71% of sessions, so firing carries no timing information. The value of Module B today is the explainable stress computation once an event is flagged, not the timing. Each of these has a concrete next step. And every decision rule was written down before the test it governed, every look at the test window is logged, and weak results are reported rather than tuned away. We used 2022 to find where the method breaks, not to tune it until it looks right. Thank you.</a:t>
             </a:r>
             <a:endParaRPr lang="en-US" dirty="0"/>
           </a:p>
@@ -10369,7 +10369,7 @@
                           <a:ea typeface="Calibri" pitchFamily="34" charset="-122"/>
                           <a:cs typeface="Calibri" pitchFamily="34" charset="-120"/>
                         </a:rPr>
-                        <a:t>Market-wide impact isn't predictive, so triggers aren't selective</a:t>
+                        <a:t>The threshold is relative (top 5% of items); with this much news it is crossed on most days</a:t>
                       </a:r>
                       <a:endParaRPr lang="en-US" sz="1100" dirty="0">
                         <a:latin typeface="Calibri" charset="0"/>
@@ -10437,7 +10437,7 @@
                           <a:ea typeface="Calibri" pitchFamily="34" charset="-122"/>
                           <a:cs typeface="Calibri" pitchFamily="34" charset="-120"/>
                         </a:rPr>
-                        <a:t>Market-level impact model; a pre-registered alert budget</a:t>
+                        <a:t>A fixed alert budget, pre-registered; a market-level impact model</a:t>
                       </a:r>
                       <a:endParaRPr lang="en-US" sz="1100" dirty="0">
                         <a:latin typeface="Calibri" charset="0"/>

</xml_diff>